<commit_message>
Add Head of SMM as a direct report to Victoria
Restructure the org chart into four branches and add a Head of SMM card
with responsibilities, reporting directly to Victoria alongside Creative
director, Head of growth and Head of PM.

Co-Authored-By: Claude Opus 4.8 <noreply@anthropic.com>
Claude-Session: https://claude.ai/code/session_01GAwnhebPqfiGQw6PMuZ5tu
</commit_message>
<xml_diff>
--- a/Структура команды маркетинга.pptx
+++ b/Структура команды маркетинга.pptx
@@ -3378,7 +3378,7 @@
           </a:fontRef>
         </p:style>
         <p:txBody>
-          <a:bodyPr rtlCol="0" anchor="ctr" wrap="square">
+          <a:bodyPr rtlCol="0" anchor="ctr" wrap="square" lIns="82296" rIns="82296">
             <a:normAutofit/>
           </a:bodyPr>
           <a:lstStyle/>
@@ -3403,8 +3403,8 @@
         </p:nvSpPr>
         <p:spPr>
           <a:xfrm>
-            <a:off x="228600" y="867160"/>
-            <a:ext cx="3759200" cy="2000000"/>
+            <a:off x="180000" y="867160"/>
+            <a:ext cx="3300000" cy="2000000"/>
           </a:xfrm>
           <a:prstGeom prst="roundRect">
             <a:avLst/>
@@ -3431,7 +3431,7 @@
           </a:fontRef>
         </p:style>
         <p:txBody>
-          <a:bodyPr rtlCol="0" anchor="t" wrap="square">
+          <a:bodyPr rtlCol="0" anchor="t" wrap="square" lIns="82296" rIns="82296">
             <a:normAutofit/>
           </a:bodyPr>
           <a:lstStyle/>
@@ -3500,8 +3500,8 @@
         </p:nvSpPr>
         <p:spPr>
           <a:xfrm>
-            <a:off x="228600" y="3027160"/>
-            <a:ext cx="3759200" cy="1200000"/>
+            <a:off x="180000" y="3027160"/>
+            <a:ext cx="3300000" cy="1200000"/>
           </a:xfrm>
           <a:prstGeom prst="roundRect">
             <a:avLst/>
@@ -3528,7 +3528,7 @@
           </a:fontRef>
         </p:style>
         <p:txBody>
-          <a:bodyPr rtlCol="0" anchor="t" wrap="square">
+          <a:bodyPr rtlCol="0" anchor="t" wrap="square" lIns="82296" rIns="82296">
             <a:normAutofit/>
           </a:bodyPr>
           <a:lstStyle/>
@@ -3586,8 +3586,8 @@
         </p:nvSpPr>
         <p:spPr>
           <a:xfrm>
-            <a:off x="228600" y="4387160"/>
-            <a:ext cx="1804600" cy="2200000"/>
+            <a:off x="180000" y="4387160"/>
+            <a:ext cx="1585000" cy="2250000"/>
           </a:xfrm>
           <a:prstGeom prst="roundRect">
             <a:avLst/>
@@ -3617,7 +3617,7 @@
           </a:fontRef>
         </p:style>
         <p:txBody>
-          <a:bodyPr rtlCol="0" anchor="t" wrap="square">
+          <a:bodyPr rtlCol="0" anchor="t" wrap="square" lIns="82296" rIns="82296">
             <a:normAutofit/>
           </a:bodyPr>
           <a:lstStyle/>
@@ -3686,8 +3686,8 @@
         </p:nvSpPr>
         <p:spPr>
           <a:xfrm>
-            <a:off x="2183200" y="4387160"/>
-            <a:ext cx="1804600" cy="2200000"/>
+            <a:off x="1895000" y="4387160"/>
+            <a:ext cx="1585000" cy="2250000"/>
           </a:xfrm>
           <a:prstGeom prst="roundRect">
             <a:avLst/>
@@ -3717,7 +3717,7 @@
           </a:fontRef>
         </p:style>
         <p:txBody>
-          <a:bodyPr rtlCol="0" anchor="t" wrap="square">
+          <a:bodyPr rtlCol="0" anchor="t" wrap="square" lIns="82296" rIns="82296">
             <a:normAutofit/>
           </a:bodyPr>
           <a:lstStyle/>
@@ -3786,8 +3786,8 @@
         </p:nvSpPr>
         <p:spPr>
           <a:xfrm>
-            <a:off x="4216400" y="867160"/>
-            <a:ext cx="3759200" cy="1690000"/>
+            <a:off x="3624000" y="867160"/>
+            <a:ext cx="2700000" cy="1800000"/>
           </a:xfrm>
           <a:prstGeom prst="roundRect">
             <a:avLst/>
@@ -3817,7 +3817,7 @@
           </a:fontRef>
         </p:style>
         <p:txBody>
-          <a:bodyPr rtlCol="0" anchor="t" wrap="square">
+          <a:bodyPr rtlCol="0" anchor="t" wrap="square" lIns="82296" rIns="82296">
             <a:normAutofit/>
           </a:bodyPr>
           <a:lstStyle/>
@@ -3886,8 +3886,8 @@
         </p:nvSpPr>
         <p:spPr>
           <a:xfrm>
-            <a:off x="4216400" y="2707160"/>
-            <a:ext cx="3759200" cy="1690000"/>
+            <a:off x="3624000" y="2817160"/>
+            <a:ext cx="2700000" cy="1800000"/>
           </a:xfrm>
           <a:prstGeom prst="roundRect">
             <a:avLst/>
@@ -3914,7 +3914,7 @@
           </a:fontRef>
         </p:style>
         <p:txBody>
-          <a:bodyPr rtlCol="0" anchor="t" wrap="square">
+          <a:bodyPr rtlCol="0" anchor="t" wrap="square" lIns="82296" rIns="82296">
             <a:normAutofit/>
           </a:bodyPr>
           <a:lstStyle/>
@@ -3983,8 +3983,8 @@
         </p:nvSpPr>
         <p:spPr>
           <a:xfrm>
-            <a:off x="4216400" y="4547160"/>
-            <a:ext cx="3759200" cy="1690000"/>
+            <a:off x="3624000" y="4767160"/>
+            <a:ext cx="2700000" cy="1800000"/>
           </a:xfrm>
           <a:prstGeom prst="roundRect">
             <a:avLst/>
@@ -4014,7 +4014,7 @@
           </a:fontRef>
         </p:style>
         <p:txBody>
-          <a:bodyPr rtlCol="0" anchor="t" wrap="square">
+          <a:bodyPr rtlCol="0" anchor="t" wrap="square" lIns="82296" rIns="82296">
             <a:normAutofit/>
           </a:bodyPr>
           <a:lstStyle/>
@@ -4083,8 +4083,8 @@
         </p:nvSpPr>
         <p:spPr>
           <a:xfrm>
-            <a:off x="8204200" y="867160"/>
-            <a:ext cx="3759200" cy="1950000"/>
+            <a:off x="6468000" y="867160"/>
+            <a:ext cx="2700000" cy="1950000"/>
           </a:xfrm>
           <a:prstGeom prst="roundRect">
             <a:avLst/>
@@ -4111,7 +4111,7 @@
           </a:fontRef>
         </p:style>
         <p:txBody>
-          <a:bodyPr rtlCol="0" anchor="t" wrap="square">
+          <a:bodyPr rtlCol="0" anchor="t" wrap="square" lIns="82296" rIns="82296">
             <a:normAutofit/>
           </a:bodyPr>
           <a:lstStyle/>
@@ -4180,8 +4180,8 @@
         </p:nvSpPr>
         <p:spPr>
           <a:xfrm>
-            <a:off x="8204200" y="3017160"/>
-            <a:ext cx="3759200" cy="1950000"/>
+            <a:off x="6468000" y="3017160"/>
+            <a:ext cx="2700000" cy="1950000"/>
           </a:xfrm>
           <a:prstGeom prst="roundRect">
             <a:avLst/>
@@ -4208,7 +4208,7 @@
           </a:fontRef>
         </p:style>
         <p:txBody>
-          <a:bodyPr rtlCol="0" anchor="t" wrap="square">
+          <a:bodyPr rtlCol="0" anchor="t" wrap="square" lIns="82296" rIns="82296">
             <a:normAutofit/>
           </a:bodyPr>
           <a:lstStyle/>
@@ -4269,9 +4269,106 @@
           </a:p>
         </p:txBody>
       </p:sp>
+      <p:sp>
+        <p:nvSpPr>
+          <p:cNvPr id="12" name="Rounded Rectangle 11"/>
+          <p:cNvSpPr/>
+          <p:nvPr/>
+        </p:nvSpPr>
+        <p:spPr>
+          <a:xfrm>
+            <a:off x="9312000" y="867160"/>
+            <a:ext cx="2700000" cy="1950000"/>
+          </a:xfrm>
+          <a:prstGeom prst="roundRect">
+            <a:avLst/>
+          </a:prstGeom>
+          <a:solidFill>
+            <a:srgbClr val="00B050"/>
+          </a:solidFill>
+          <a:ln>
+            <a:noFill/>
+          </a:ln>
+        </p:spPr>
+        <p:style>
+          <a:lnRef idx="1">
+            <a:schemeClr val="accent1"/>
+          </a:lnRef>
+          <a:fillRef idx="3">
+            <a:schemeClr val="accent1"/>
+          </a:fillRef>
+          <a:effectRef idx="2">
+            <a:schemeClr val="accent1"/>
+          </a:effectRef>
+          <a:fontRef idx="minor">
+            <a:schemeClr val="lt1"/>
+          </a:fontRef>
+        </p:style>
+        <p:txBody>
+          <a:bodyPr rtlCol="0" anchor="t" wrap="square" lIns="82296" rIns="82296">
+            <a:normAutofit/>
+          </a:bodyPr>
+          <a:lstStyle/>
+          <a:p>
+            <a:pPr algn="ctr"/>
+            <a:r>
+              <a:rPr sz="1400" b="1">
+                <a:solidFill>
+                  <a:srgbClr val="FFFFFF"/>
+                </a:solidFill>
+              </a:rPr>
+              <a:t>Head of SMM</a:t>
+            </a:r>
+          </a:p>
+          <a:p>
+            <a:pPr algn="l"/>
+            <a:r>
+              <a:rPr sz="1000">
+                <a:solidFill>
+                  <a:srgbClr val="FFFFFF"/>
+                </a:solidFill>
+              </a:rPr>
+              <a:t>- SMM-стратегия и развитие соцсетей бренда (Instagram, TikTok, YouTube, Telegram).</a:t>
+            </a:r>
+          </a:p>
+          <a:p>
+            <a:pPr algn="l"/>
+            <a:r>
+              <a:rPr sz="1000">
+                <a:solidFill>
+                  <a:srgbClr val="FFFFFF"/>
+                </a:solidFill>
+              </a:rPr>
+              <a:t>- Контент-план, продакшн и публикации: рубрики, форматы, тон коммуникации.</a:t>
+            </a:r>
+          </a:p>
+          <a:p>
+            <a:pPr algn="l"/>
+            <a:r>
+              <a:rPr sz="1000">
+                <a:solidFill>
+                  <a:srgbClr val="FFFFFF"/>
+                </a:solidFill>
+              </a:rPr>
+              <a:t>- Комьюнити-менеджмент: вовлечение, engagement, работа с комментариями и обратной связью.</a:t>
+            </a:r>
+          </a:p>
+          <a:p>
+            <a:pPr algn="l"/>
+            <a:r>
+              <a:rPr sz="1000">
+                <a:solidFill>
+                  <a:srgbClr val="FFFFFF"/>
+                </a:solidFill>
+              </a:rPr>
+              <a:t>- Аналитика и рост метрик: охваты, подписчики, ER, переходы и заявки из соцсетей.</a:t>
+            </a:r>
+          </a:p>
+        </p:txBody>
+      </p:sp>
       <p:cxnSp>
         <p:nvCxnSpPr>
-          <p:cNvPr id="12" name="Connector 11"/>
+          <p:cNvPr id="13" name="Connector 12"/>
           <p:cNvCxnSpPr>
             <a:stCxn id="2" idx="2"/>
             <a:endCxn id="3" idx="0"/>
@@ -4280,8 +4377,8 @@
         </p:nvCxnSpPr>
         <p:spPr>
           <a:xfrm flipH="1">
-            <a:off x="2108200" y="607160"/>
-            <a:ext cx="3987800" cy="260000"/>
+            <a:off x="1830000" y="607160"/>
+            <a:ext cx="4266000" cy="260000"/>
           </a:xfrm>
           <a:prstGeom prst="line">
             <a:avLst/>
@@ -4310,7 +4407,7 @@
       </p:cxnSp>
       <p:cxnSp>
         <p:nvCxnSpPr>
-          <p:cNvPr id="13" name="Connector 12"/>
+          <p:cNvPr id="14" name="Connector 13"/>
           <p:cNvCxnSpPr>
             <a:stCxn id="2" idx="2"/>
             <a:endCxn id="7" idx="0"/>
@@ -4319,8 +4416,8 @@
         </p:nvCxnSpPr>
         <p:spPr>
           <a:xfrm flipH="1">
-            <a:off x="6096000" y="607160"/>
-            <a:ext cx="0" cy="260000"/>
+            <a:off x="4974000" y="607160"/>
+            <a:ext cx="1122000" cy="260000"/>
           </a:xfrm>
           <a:prstGeom prst="line">
             <a:avLst/>
@@ -4349,7 +4446,7 @@
       </p:cxnSp>
       <p:cxnSp>
         <p:nvCxnSpPr>
-          <p:cNvPr id="14" name="Connector 13"/>
+          <p:cNvPr id="15" name="Connector 14"/>
           <p:cNvCxnSpPr>
             <a:stCxn id="2" idx="2"/>
             <a:endCxn id="10" idx="0"/>
@@ -4359,7 +4456,7 @@
         <p:spPr>
           <a:xfrm>
             <a:off x="6096000" y="607160"/>
-            <a:ext cx="3987800" cy="260000"/>
+            <a:ext cx="1722000" cy="260000"/>
           </a:xfrm>
           <a:prstGeom prst="line">
             <a:avLst/>
@@ -4388,7 +4485,46 @@
       </p:cxnSp>
       <p:cxnSp>
         <p:nvCxnSpPr>
-          <p:cNvPr id="15" name="Connector 14"/>
+          <p:cNvPr id="16" name="Connector 15"/>
+          <p:cNvCxnSpPr>
+            <a:stCxn id="2" idx="2"/>
+            <a:endCxn id="12" idx="0"/>
+          </p:cNvCxnSpPr>
+          <p:nvPr/>
+        </p:nvCxnSpPr>
+        <p:spPr>
+          <a:xfrm>
+            <a:off x="6096000" y="607160"/>
+            <a:ext cx="4566000" cy="260000"/>
+          </a:xfrm>
+          <a:prstGeom prst="line">
+            <a:avLst/>
+          </a:prstGeom>
+          <a:ln w="12700">
+            <a:solidFill>
+              <a:srgbClr val="404040"/>
+            </a:solidFill>
+            <a:tailEnd type="triangle"/>
+          </a:ln>
+        </p:spPr>
+        <p:style>
+          <a:lnRef idx="2">
+            <a:schemeClr val="accent1"/>
+          </a:lnRef>
+          <a:fillRef idx="0">
+            <a:schemeClr val="accent1"/>
+          </a:fillRef>
+          <a:effectRef idx="1">
+            <a:schemeClr val="accent1"/>
+          </a:effectRef>
+          <a:fontRef idx="minor">
+            <a:schemeClr val="tx1"/>
+          </a:fontRef>
+        </p:style>
+      </p:cxnSp>
+      <p:cxnSp>
+        <p:nvCxnSpPr>
+          <p:cNvPr id="17" name="Connector 16"/>
           <p:cNvCxnSpPr>
             <a:stCxn id="3" idx="2"/>
             <a:endCxn id="4" idx="0"/>
@@ -4397,7 +4533,7 @@
         </p:nvCxnSpPr>
         <p:spPr>
           <a:xfrm flipH="1">
-            <a:off x="2108200" y="2867160"/>
+            <a:off x="1830000" y="2867160"/>
             <a:ext cx="0" cy="160000"/>
           </a:xfrm>
           <a:prstGeom prst="line">
@@ -4427,7 +4563,7 @@
       </p:cxnSp>
       <p:cxnSp>
         <p:nvCxnSpPr>
-          <p:cNvPr id="16" name="Connector 15"/>
+          <p:cNvPr id="18" name="Connector 17"/>
           <p:cNvCxnSpPr>
             <a:stCxn id="4" idx="2"/>
             <a:endCxn id="5" idx="0"/>
@@ -4436,8 +4572,8 @@
         </p:nvCxnSpPr>
         <p:spPr>
           <a:xfrm flipH="1">
-            <a:off x="1130900" y="4227160"/>
-            <a:ext cx="977300" cy="160000"/>
+            <a:off x="972500" y="4227160"/>
+            <a:ext cx="857500" cy="160000"/>
           </a:xfrm>
           <a:prstGeom prst="line">
             <a:avLst/>
@@ -4466,7 +4602,7 @@
       </p:cxnSp>
       <p:cxnSp>
         <p:nvCxnSpPr>
-          <p:cNvPr id="17" name="Connector 16"/>
+          <p:cNvPr id="19" name="Connector 18"/>
           <p:cNvCxnSpPr>
             <a:stCxn id="4" idx="2"/>
             <a:endCxn id="6" idx="0"/>
@@ -4475,8 +4611,8 @@
         </p:nvCxnSpPr>
         <p:spPr>
           <a:xfrm>
-            <a:off x="2108200" y="4227160"/>
-            <a:ext cx="977300" cy="160000"/>
+            <a:off x="1830000" y="4227160"/>
+            <a:ext cx="857500" cy="160000"/>
           </a:xfrm>
           <a:prstGeom prst="line">
             <a:avLst/>
@@ -4505,7 +4641,7 @@
       </p:cxnSp>
       <p:cxnSp>
         <p:nvCxnSpPr>
-          <p:cNvPr id="18" name="Connector 17"/>
+          <p:cNvPr id="20" name="Connector 19"/>
           <p:cNvCxnSpPr>
             <a:stCxn id="7" idx="2"/>
             <a:endCxn id="8" idx="0"/>
@@ -4514,7 +4650,7 @@
         </p:nvCxnSpPr>
         <p:spPr>
           <a:xfrm flipH="1">
-            <a:off x="6096000" y="2557160"/>
+            <a:off x="4974000" y="2667160"/>
             <a:ext cx="0" cy="150000"/>
           </a:xfrm>
           <a:prstGeom prst="line">
@@ -4544,7 +4680,7 @@
       </p:cxnSp>
       <p:cxnSp>
         <p:nvCxnSpPr>
-          <p:cNvPr id="19" name="Connector 18"/>
+          <p:cNvPr id="21" name="Connector 20"/>
           <p:cNvCxnSpPr>
             <a:stCxn id="8" idx="2"/>
             <a:endCxn id="9" idx="0"/>
@@ -4553,7 +4689,7 @@
         </p:nvCxnSpPr>
         <p:spPr>
           <a:xfrm flipH="1">
-            <a:off x="6096000" y="4397160"/>
+            <a:off x="4974000" y="4617160"/>
             <a:ext cx="0" cy="150000"/>
           </a:xfrm>
           <a:prstGeom prst="line">
@@ -4583,7 +4719,7 @@
       </p:cxnSp>
       <p:cxnSp>
         <p:nvCxnSpPr>
-          <p:cNvPr id="20" name="Connector 19"/>
+          <p:cNvPr id="22" name="Connector 21"/>
           <p:cNvCxnSpPr>
             <a:stCxn id="10" idx="2"/>
             <a:endCxn id="11" idx="0"/>
@@ -4592,7 +4728,7 @@
         </p:nvCxnSpPr>
         <p:spPr>
           <a:xfrm flipH="1">
-            <a:off x="10083800" y="2817160"/>
+            <a:off x="7818000" y="2817160"/>
             <a:ext cx="0" cy="200000"/>
           </a:xfrm>
           <a:prstGeom prst="line">

</xml_diff>

<commit_message>
Fix grammar/typos in Creative director and Head of production
- Creative director: fix 'капмпании'->'кампании', merge dangling
  'Интегрированные' into 'Интегрированные маркетинговые кампании', fix
  case agreement 'креативные концепции и бренд-коммуникации'.
- Head of production: fix 'Операционна'->'Операционная', add ё and
  consistent end punctuation.
- Preserve manual edits: Senior PPC 'по CPA', new SMM bullet on originals.

Co-Authored-By: Claude Opus 4.8 <noreply@anthropic.com>
Claude-Session: https://claude.ai/code/session_01GAwnhebPqfiGQw6PMuZ5tu
</commit_message>
<xml_diff>
--- a/Структура команды маркетинга.pptx
+++ b/Структура команды маркетинга.pptx
@@ -3454,7 +3454,7 @@
                   <a:srgbClr val="FFFFFF"/>
                 </a:solidFill>
               </a:rPr>
-              <a:t>- Бренд: позиционирование, ToV, упаковка. Интегрированные</a:t>
+              <a:t>- Бренд: позиционирование, ToV, упаковка.</a:t>
             </a:r>
           </a:p>
           <a:p>
@@ -3465,7 +3465,7 @@
                   <a:srgbClr val="FFFFFF"/>
                 </a:solidFill>
               </a:rPr>
-              <a:t>- Маркетинговые капмпании: создание и масштабирование идей через разные инструменты продвижения.</a:t>
+              <a:t>- Интегрированные маркетинговые кампании: создание и масштабирование идей через разные инструменты продвижения.</a:t>
             </a:r>
           </a:p>
           <a:p>
@@ -3476,7 +3476,7 @@
                   <a:srgbClr val="FFFFFF"/>
                 </a:solidFill>
               </a:rPr>
-              <a:t>- Originals: креативные концепций и бренд-коммуникаций.</a:t>
+              <a:t>- Originals: креативные концепции и бренд-коммуникации.</a:t>
             </a:r>
           </a:p>
           <a:p>
@@ -3551,7 +3551,7 @@
                   <a:srgbClr val="FFFFFF"/>
                 </a:solidFill>
               </a:rPr>
-              <a:t>- Операционна работа с командой: дизайнеры, монтажеры</a:t>
+              <a:t>- Операционная работа с командой: дизайнеры, монтажёры.</a:t>
             </a:r>
           </a:p>
           <a:p>
@@ -3562,7 +3562,7 @@
                   <a:srgbClr val="FFFFFF"/>
                 </a:solidFill>
               </a:rPr>
-              <a:t>- Операционная работа с подрядчиками: брифинг, отслеживание работ и сроков, документооборот</a:t>
+              <a:t>- Операционная работа с подрядчиками: брифинг, отслеживание работ и сроков, документооборот.</a:t>
             </a:r>
           </a:p>
           <a:p>
@@ -3573,7 +3573,7 @@
                   <a:srgbClr val="FFFFFF"/>
                 </a:solidFill>
               </a:rPr>
-              <a:t>- Организация съемок любой сложности</a:t>
+              <a:t>- Организация съёмок любой сложности.</a:t>
             </a:r>
           </a:p>
         </p:txBody>
@@ -3959,7 +3959,7 @@
                   <a:srgbClr val="FFFFFF"/>
                 </a:solidFill>
               </a:rPr>
-              <a:t>- Оптимизация ставок и бюджетов по CPA / ROAS.</a:t>
+              <a:t>- Оптимизация ставок и бюджетов по CPA.</a:t>
             </a:r>
           </a:p>
           <a:p>
@@ -4278,7 +4278,7 @@
         <p:spPr>
           <a:xfrm>
             <a:off x="9312000" y="867160"/>
-            <a:ext cx="2700000" cy="1950000"/>
+            <a:ext cx="2700000" cy="2350000"/>
           </a:xfrm>
           <a:prstGeom prst="roundRect">
             <a:avLst/>
@@ -4362,6 +4362,17 @@
                 </a:solidFill>
               </a:rPr>
               <a:t>- Аналитика и рост метрик: охваты, подписчики, ER, переходы и заявки из соцсетей.</a:t>
+            </a:r>
+          </a:p>
+          <a:p>
+            <a:pPr algn="l"/>
+            <a:r>
+              <a:rPr sz="1000">
+                <a:solidFill>
+                  <a:srgbClr val="FFFFFF"/>
+                </a:solidFill>
+              </a:rPr>
+              <a:t>- Работа с originals в соц медиа.</a:t>
             </a:r>
           </a:p>
         </p:txBody>

</xml_diff>

<commit_message>
Enrich Head of production with planning and budget responsibilities
Add two head-level bullets: team capacity/resource planning (pipeline,
priorities, deadlines) and production budget / cost control. Adjust
column-1 card heights to fit.

Co-Authored-By: Claude Opus 4.8 <noreply@anthropic.com>
Claude-Session: https://claude.ai/code/session_01GAwnhebPqfiGQw6PMuZ5tu
</commit_message>
<xml_diff>
--- a/Структура команды маркетинга.pptx
+++ b/Структура команды маркетинга.pptx
@@ -3404,7 +3404,7 @@
         <p:spPr>
           <a:xfrm>
             <a:off x="180000" y="867160"/>
-            <a:ext cx="3300000" cy="2000000"/>
+            <a:ext cx="3300000" cy="1850000"/>
           </a:xfrm>
           <a:prstGeom prst="roundRect">
             <a:avLst/>
@@ -3500,8 +3500,8 @@
         </p:nvSpPr>
         <p:spPr>
           <a:xfrm>
-            <a:off x="180000" y="3027160"/>
-            <a:ext cx="3300000" cy="1200000"/>
+            <a:off x="180000" y="2877160"/>
+            <a:ext cx="3300000" cy="1600000"/>
           </a:xfrm>
           <a:prstGeom prst="roundRect">
             <a:avLst/>
@@ -3576,6 +3576,28 @@
               <a:t>- Организация съёмок любой сложности.</a:t>
             </a:r>
           </a:p>
+          <a:p>
+            <a:pPr algn="l"/>
+            <a:r>
+              <a:rPr sz="1000">
+                <a:solidFill>
+                  <a:srgbClr val="FFFFFF"/>
+                </a:solidFill>
+              </a:rPr>
+              <a:t>- Планирование загрузки и ресурсов команды: пайплайн, приоритеты, сроки.</a:t>
+            </a:r>
+          </a:p>
+          <a:p>
+            <a:pPr algn="l"/>
+            <a:r>
+              <a:rPr sz="1000">
+                <a:solidFill>
+                  <a:srgbClr val="FFFFFF"/>
+                </a:solidFill>
+              </a:rPr>
+              <a:t>- Бюджет продакшна и контроль затрат.</a:t>
+            </a:r>
+          </a:p>
         </p:txBody>
       </p:sp>
       <p:sp>
@@ -3586,8 +3608,8 @@
         </p:nvSpPr>
         <p:spPr>
           <a:xfrm>
-            <a:off x="180000" y="4387160"/>
-            <a:ext cx="1585000" cy="2250000"/>
+            <a:off x="180000" y="4637160"/>
+            <a:ext cx="1585000" cy="2000000"/>
           </a:xfrm>
           <a:prstGeom prst="roundRect">
             <a:avLst/>
@@ -3686,8 +3708,8 @@
         </p:nvSpPr>
         <p:spPr>
           <a:xfrm>
-            <a:off x="1895000" y="4387160"/>
-            <a:ext cx="1585000" cy="2250000"/>
+            <a:off x="1895000" y="4637160"/>
+            <a:ext cx="1585000" cy="2000000"/>
           </a:xfrm>
           <a:prstGeom prst="roundRect">
             <a:avLst/>
@@ -4544,7 +4566,7 @@
         </p:nvCxnSpPr>
         <p:spPr>
           <a:xfrm flipH="1">
-            <a:off x="1830000" y="2867160"/>
+            <a:off x="1830000" y="2717160"/>
             <a:ext cx="0" cy="160000"/>
           </a:xfrm>
           <a:prstGeom prst="line">
@@ -4583,7 +4605,7 @@
         </p:nvCxnSpPr>
         <p:spPr>
           <a:xfrm flipH="1">
-            <a:off x="972500" y="4227160"/>
+            <a:off x="972500" y="4477160"/>
             <a:ext cx="857500" cy="160000"/>
           </a:xfrm>
           <a:prstGeom prst="line">
@@ -4622,7 +4644,7 @@
         </p:nvCxnSpPr>
         <p:spPr>
           <a:xfrm>
-            <a:off x="1830000" y="4227160"/>
+            <a:off x="1830000" y="4477160"/>
             <a:ext cx="857500" cy="160000"/>
           </a:xfrm>
           <a:prstGeom prst="line">

</xml_diff>

<commit_message>
Round out responsibilities for all remaining roles
Make every role description complete and consistent at Head/Senior level:
- Head of growth: add full-funnel growth strategy (acquisition->retention)
- Senior PPC: add audience building & tracking (pixels, retargeting)
- Media manager: add channel selection/negotiation
- Head of PM: add resource planning and exec reporting; include SMM in coordination
- Senior BTL: add on-site coordination/logistics
- Head of SMM: add team management
Tighten wording and adjust card heights to fit.

Co-Authored-By: Claude Opus 4.8 <noreply@anthropic.com>
Claude-Session: https://claude.ai/code/session_01GAwnhebPqfiGQw6PMuZ5tu
</commit_message>
<xml_diff>
--- a/Структура команды маркетинга.pptx
+++ b/Структура команды маркетинга.pptx
@@ -3809,7 +3809,7 @@
         <p:spPr>
           <a:xfrm>
             <a:off x="3624000" y="867160"/>
-            <a:ext cx="2700000" cy="1800000"/>
+            <a:ext cx="2700000" cy="1850000"/>
           </a:xfrm>
           <a:prstGeom prst="roundRect">
             <a:avLst/>
@@ -3862,7 +3862,7 @@
                   <a:srgbClr val="FFFFFF"/>
                 </a:solidFill>
               </a:rPr>
-              <a:t>- Перформанс-маркетинг: стратегия привлечения и масштабирования трафика по платным каналам.</a:t>
+              <a:t>- Стратегия роста: привлечение, активация, удержание, монетизация.</a:t>
             </a:r>
           </a:p>
           <a:p>
@@ -3873,7 +3873,7 @@
                   <a:srgbClr val="FFFFFF"/>
                 </a:solidFill>
               </a:rPr>
-              <a:t>- Управление командой PPC, медиабаингом и аналитикой.</a:t>
+              <a:t>- Перформанс-маркетинг и медиабаинг, масштабирование платного трафика.</a:t>
             </a:r>
           </a:p>
           <a:p>
@@ -3884,7 +3884,7 @@
                   <a:srgbClr val="FFFFFF"/>
                 </a:solidFill>
               </a:rPr>
-              <a:t>- Юнит-экономика: CAC, LTV, ROMI, контроль и оптимизация бюджета.</a:t>
+              <a:t>- Управление командой PPC, медиа и аналитикой.</a:t>
             </a:r>
           </a:p>
           <a:p>
@@ -3895,7 +3895,18 @@
                   <a:srgbClr val="FFFFFF"/>
                 </a:solidFill>
               </a:rPr>
-              <a:t>- Рост ключевых метрик через тестирование гипотез и воронок.</a:t>
+              <a:t>- Юнит-экономика: CAC, LTV, ROMI; оптимизация бюджета.</a:t>
+            </a:r>
+          </a:p>
+          <a:p>
+            <a:pPr algn="l"/>
+            <a:r>
+              <a:rPr sz="1000">
+                <a:solidFill>
+                  <a:srgbClr val="FFFFFF"/>
+                </a:solidFill>
+              </a:rPr>
+              <a:t>- Рост метрик через гипотезы, A/B и оптимизацию воронок.</a:t>
             </a:r>
           </a:p>
         </p:txBody>
@@ -3908,8 +3919,8 @@
         </p:nvSpPr>
         <p:spPr>
           <a:xfrm>
-            <a:off x="3624000" y="2817160"/>
-            <a:ext cx="2700000" cy="1800000"/>
+            <a:off x="3624000" y="2827160"/>
+            <a:ext cx="2700000" cy="1850000"/>
           </a:xfrm>
           <a:prstGeom prst="roundRect">
             <a:avLst/>
@@ -3959,7 +3970,7 @@
                   <a:srgbClr val="FFFFFF"/>
                 </a:solidFill>
               </a:rPr>
-              <a:t>- Настройка и ведение рекламных кампаний (Google Ads, Meta, контекст, таргет).</a:t>
+              <a:t>- Ведение рекламных кампаний: Google Ads, Meta, контекст, таргет.</a:t>
             </a:r>
           </a:p>
           <a:p>
@@ -3970,7 +3981,18 @@
                   <a:srgbClr val="FFFFFF"/>
                 </a:solidFill>
               </a:rPr>
-              <a:t>- A/B-тесты креативов, аудиторий и посадочных страниц.</a:t>
+              <a:t>- Аудитории и трекинг: пиксели, конверсии, ретаргетинг, look-alike.</a:t>
+            </a:r>
+          </a:p>
+          <a:p>
+            <a:pPr algn="l"/>
+            <a:r>
+              <a:rPr sz="1000">
+                <a:solidFill>
+                  <a:srgbClr val="FFFFFF"/>
+                </a:solidFill>
+              </a:rPr>
+              <a:t>- A/B-тесты креативов, аудиторий и посадочных.</a:t>
             </a:r>
           </a:p>
           <a:p>
@@ -4005,8 +4027,8 @@
         </p:nvSpPr>
         <p:spPr>
           <a:xfrm>
-            <a:off x="3624000" y="4767160"/>
-            <a:ext cx="2700000" cy="1800000"/>
+            <a:off x="3624000" y="4787160"/>
+            <a:ext cx="2700000" cy="1850000"/>
           </a:xfrm>
           <a:prstGeom prst="roundRect">
             <a:avLst/>
@@ -4059,7 +4081,7 @@
                   <a:srgbClr val="FFFFFF"/>
                 </a:solidFill>
               </a:rPr>
-              <a:t>- Медиапланирование и закупка размещений у площадок и блогеров.</a:t>
+              <a:t>- Медиапланирование и подбор площадок под цели кампании.</a:t>
             </a:r>
           </a:p>
           <a:p>
@@ -4070,7 +4092,7 @@
                   <a:srgbClr val="FFFFFF"/>
                 </a:solidFill>
               </a:rPr>
-              <a:t>- Ведение рекламного календаря и контроль выходов.</a:t>
+              <a:t>- Закупка размещений у площадок и блогеров, переговоры.</a:t>
             </a:r>
           </a:p>
           <a:p>
@@ -4081,7 +4103,18 @@
                   <a:srgbClr val="FFFFFF"/>
                 </a:solidFill>
               </a:rPr>
-              <a:t>- Работа с инфлюенсерами: отбор, переговоры, ТЗ, отчётность.</a:t>
+              <a:t>- Инфлюенсеры: отбор, ТЗ, согласование, отчётность.</a:t>
+            </a:r>
+          </a:p>
+          <a:p>
+            <a:pPr algn="l"/>
+            <a:r>
+              <a:rPr sz="1000">
+                <a:solidFill>
+                  <a:srgbClr val="FFFFFF"/>
+                </a:solidFill>
+              </a:rPr>
+              <a:t>- Рекламный календарь и контроль выходов.</a:t>
             </a:r>
           </a:p>
           <a:p>
@@ -4106,7 +4139,7 @@
         <p:spPr>
           <a:xfrm>
             <a:off x="6468000" y="867160"/>
-            <a:ext cx="2700000" cy="1950000"/>
+            <a:ext cx="2700000" cy="2050000"/>
           </a:xfrm>
           <a:prstGeom prst="roundRect">
             <a:avLst/>
@@ -4156,7 +4189,7 @@
                   <a:srgbClr val="FFFFFF"/>
                 </a:solidFill>
               </a:rPr>
-              <a:t>- Управление проектами и процессами маркетинга: планирование, приоритизация, дедлайны.</a:t>
+              <a:t>- Управление проектами и процессами: планирование, приоритизация, дедлайны.</a:t>
             </a:r>
           </a:p>
           <a:p>
@@ -4167,7 +4200,7 @@
                   <a:srgbClr val="FFFFFF"/>
                 </a:solidFill>
               </a:rPr>
-              <a:t>- Координация между командами (креатив, продакшн, перформанс).</a:t>
+              <a:t>- Координация команд: креатив, продакшн, перформанс, SMM.</a:t>
             </a:r>
           </a:p>
           <a:p>
@@ -4178,7 +4211,7 @@
                   <a:srgbClr val="FFFFFF"/>
                 </a:solidFill>
               </a:rPr>
-              <a:t>- Внедрение и поддержка таск-трекинга и регламентов.</a:t>
+              <a:t>- Ресурсное планирование и контроль загрузки команд.</a:t>
             </a:r>
           </a:p>
           <a:p>
@@ -4189,7 +4222,18 @@
                   <a:srgbClr val="FFFFFF"/>
                 </a:solidFill>
               </a:rPr>
-              <a:t>- Контроль ресурсов, рисков и статусов по проектам.</a:t>
+              <a:t>- Таск-трекинг, регламенты и документооборот.</a:t>
+            </a:r>
+          </a:p>
+          <a:p>
+            <a:pPr algn="l"/>
+            <a:r>
+              <a:rPr sz="1000">
+                <a:solidFill>
+                  <a:srgbClr val="FFFFFF"/>
+                </a:solidFill>
+              </a:rPr>
+              <a:t>- Контроль рисков, статусов и отчётность для руководства.</a:t>
             </a:r>
           </a:p>
         </p:txBody>
@@ -4202,8 +4246,8 @@
         </p:nvSpPr>
         <p:spPr>
           <a:xfrm>
-            <a:off x="6468000" y="3017160"/>
-            <a:ext cx="2700000" cy="1950000"/>
+            <a:off x="6468000" y="3117160"/>
+            <a:ext cx="2700000" cy="2050000"/>
           </a:xfrm>
           <a:prstGeom prst="roundRect">
             <a:avLst/>
@@ -4264,7 +4308,7 @@
                   <a:srgbClr val="FFFFFF"/>
                 </a:solidFill>
               </a:rPr>
-              <a:t>- Работа с подрядчиками: промо, ивенты, мерч, POSM.</a:t>
+              <a:t>- Подрядчики: промо, ивенты, мерч, POSM.</a:t>
             </a:r>
           </a:p>
           <a:p>
@@ -4275,7 +4319,7 @@
                   <a:srgbClr val="FFFFFF"/>
                 </a:solidFill>
               </a:rPr>
-              <a:t>- Трейд-маркетинг и партнёрские активации.</a:t>
+              <a:t>- Трейд-маркетинг и партнёрские/кросс-промо активации.</a:t>
             </a:r>
           </a:p>
           <a:p>
@@ -4286,7 +4330,18 @@
                   <a:srgbClr val="FFFFFF"/>
                 </a:solidFill>
               </a:rPr>
-              <a:t>- Контроль бюджета, сроков и эффективности активностей.</a:t>
+              <a:t>- Координация на площадке: логистика, персонал, сопровождение.</a:t>
+            </a:r>
+          </a:p>
+          <a:p>
+            <a:pPr algn="l"/>
+            <a:r>
+              <a:rPr sz="1000">
+                <a:solidFill>
+                  <a:srgbClr val="FFFFFF"/>
+                </a:solidFill>
+              </a:rPr>
+              <a:t>- Контроль бюджета, сроков и эффективности.</a:t>
             </a:r>
           </a:p>
         </p:txBody>
@@ -4300,7 +4355,7 @@
         <p:spPr>
           <a:xfrm>
             <a:off x="9312000" y="867160"/>
-            <a:ext cx="2700000" cy="2350000"/>
+            <a:ext cx="2700000" cy="2700000"/>
           </a:xfrm>
           <a:prstGeom prst="roundRect">
             <a:avLst/>
@@ -4350,7 +4405,7 @@
                   <a:srgbClr val="FFFFFF"/>
                 </a:solidFill>
               </a:rPr>
-              <a:t>- SMM-стратегия и развитие соцсетей бренда (Instagram, TikTok, YouTube, Telegram).</a:t>
+              <a:t>- SMM-стратегия и развитие соцсетей (Instagram, TikTok, YouTube, Telegram).</a:t>
             </a:r>
           </a:p>
           <a:p>
@@ -4361,7 +4416,7 @@
                   <a:srgbClr val="FFFFFF"/>
                 </a:solidFill>
               </a:rPr>
-              <a:t>- Контент-план, продакшн и публикации: рубрики, форматы, тон коммуникации.</a:t>
+              <a:t>- Управление командой SMM: контент-менеджеры, копирайтеры, таргетолог.</a:t>
             </a:r>
           </a:p>
           <a:p>
@@ -4372,7 +4427,7 @@
                   <a:srgbClr val="FFFFFF"/>
                 </a:solidFill>
               </a:rPr>
-              <a:t>- Комьюнити-менеджмент: вовлечение, engagement, работа с комментариями и обратной связью.</a:t>
+              <a:t>- Контент-план, продакшн и публикации: рубрики, форматы, тон.</a:t>
             </a:r>
           </a:p>
           <a:p>
@@ -4383,7 +4438,7 @@
                   <a:srgbClr val="FFFFFF"/>
                 </a:solidFill>
               </a:rPr>
-              <a:t>- Аналитика и рост метрик: охваты, подписчики, ER, переходы и заявки из соцсетей.</a:t>
+              <a:t>- Работа с originals в соц медиа.</a:t>
             </a:r>
           </a:p>
           <a:p>
@@ -4394,7 +4449,18 @@
                   <a:srgbClr val="FFFFFF"/>
                 </a:solidFill>
               </a:rPr>
-              <a:t>- Работа с originals в соц медиа.</a:t>
+              <a:t>- Комьюнити-менеджмент: вовлечение, engagement, обратная связь.</a:t>
+            </a:r>
+          </a:p>
+          <a:p>
+            <a:pPr algn="l"/>
+            <a:r>
+              <a:rPr sz="1000">
+                <a:solidFill>
+                  <a:srgbClr val="FFFFFF"/>
+                </a:solidFill>
+              </a:rPr>
+              <a:t>- Аналитика и рост метрик: охваты, подписчики, ER, заявки.</a:t>
             </a:r>
           </a:p>
         </p:txBody>
@@ -4683,8 +4749,8 @@
         </p:nvCxnSpPr>
         <p:spPr>
           <a:xfrm flipH="1">
-            <a:off x="4974000" y="2667160"/>
-            <a:ext cx="0" cy="150000"/>
+            <a:off x="4974000" y="2717160"/>
+            <a:ext cx="0" cy="110000"/>
           </a:xfrm>
           <a:prstGeom prst="line">
             <a:avLst/>
@@ -4722,8 +4788,8 @@
         </p:nvCxnSpPr>
         <p:spPr>
           <a:xfrm flipH="1">
-            <a:off x="4974000" y="4617160"/>
-            <a:ext cx="0" cy="150000"/>
+            <a:off x="4974000" y="4677160"/>
+            <a:ext cx="0" cy="110000"/>
           </a:xfrm>
           <a:prstGeom prst="line">
             <a:avLst/>
@@ -4761,7 +4827,7 @@
         </p:nvCxnSpPr>
         <p:spPr>
           <a:xfrm flipH="1">
-            <a:off x="7818000" y="2817160"/>
+            <a:off x="7818000" y="2917160"/>
             <a:ext cx="0" cy="200000"/>
           </a:xfrm>
           <a:prstGeom prst="line">

</xml_diff>